<commit_message>
Add live application website link (https://sglt2-drug-discovery.streamlit.app/) to README and presentation
</commit_message>
<xml_diff>
--- a/Presentasi_SGLT2_Drug_Discovery_Terbaru.pptx
+++ b/Presentasi_SGLT2_Drug_Discovery_Terbaru.pptx
@@ -3667,14 +3667,14 @@
           </a:p>
           <a:p>
             <a:pPr>
-              <a:defRPr sz="1200">
+              <a:defRPr sz="1150">
                 <a:solidFill>
                   <a:srgbClr val="94A3B8"/>
                 </a:solidFill>
               </a:defRPr>
             </a:pPr>
             <a:r>
-              <a:t>👨‍🏫 Dosen Pengampu / Pembimbing: Prof. Arry   |   🌐 Publikasi: github.com/hannachristina51-gif/SGLT2_Drug_Discovery   |   Update Terbaru: Oktober 2026</a:t>
+              <a:t>👨‍🏫 Dosen Pengampu / Pembimbing: Prof. Arry   |   🌐 Web App: https://sglt2-drug-discovery.streamlit.app/   |   🐙 GitHub: hannachristina51-gif/SGLT2_Drug_Discovery</a:t>
             </a:r>
           </a:p>
         </p:txBody>
@@ -4047,7 +4047,7 @@
               <a:spcAft>
                 <a:spcPts val="600"/>
               </a:spcAft>
-              <a:defRPr sz="1400" b="1">
+              <a:defRPr sz="1350" b="1">
                 <a:solidFill>
                   <a:srgbClr val="1E3A8A"/>
                 </a:solidFill>
@@ -4055,7 +4055,7 @@
               </a:defRPr>
             </a:pPr>
             <a:r>
-              <a:t>☁️ 1. Optimasi Khusus Streamlit Community Cloud</a:t>
+              <a:t>☁️ 1. Website Live: https://sglt2-drug-discovery.streamlit.app/</a:t>
             </a:r>
           </a:p>
           <a:p>
@@ -4065,22 +4065,22 @@
               </a:spcAft>
             </a:pPr>
             <a:r>
-              <a:rPr b="1" sz="1080">
+              <a:rPr b="1" sz="1050">
                 <a:solidFill>
                   <a:srgbClr val="0F172A"/>
                 </a:solidFill>
                 <a:latin typeface="Calibri"/>
               </a:rPr>
-              <a:t>• Self-Contained Library Bundling (./joblib &amp; ./fpdf): </a:t>
-            </a:r>
-            <a:r>
-              <a:rPr b="0" sz="1080">
+              <a:t>• Akses Publik Instan (Streamlit Cloud): </a:t>
+            </a:r>
+            <a:r>
+              <a:rPr b="0" sz="1050">
                 <a:solidFill>
                   <a:srgbClr val="475569"/>
                 </a:solidFill>
                 <a:latin typeface="Calibri"/>
               </a:rPr>
-              <a:t>Membundel pustaka pure-Python joblib dan fpdf2 langsung di repositori untuk melewati pembatasan PEP 668 pada container Debian Linux / Python 3.11–3.14.</a:t>
+              <a:t>Aplikasi telah online dan dapat diakses langsung melalui https://sglt2-drug-discovery.streamlit.app/ tanpa instalasi lokal.</a:t>
             </a:r>
           </a:p>
           <a:p>
@@ -4090,22 +4090,22 @@
               </a:spcAft>
             </a:pPr>
             <a:r>
-              <a:rPr b="1" sz="1080">
+              <a:rPr b="1" sz="1050">
                 <a:solidFill>
                   <a:srgbClr val="0F172A"/>
                 </a:solidFill>
                 <a:latin typeface="Calibri"/>
               </a:rPr>
-              <a:t>• Dynamic Site-Packages Discovery: </a:t>
-            </a:r>
-            <a:r>
-              <a:rPr b="0" sz="1080">
+              <a:t>• Self-Contained Bundling (./joblib &amp; ./fpdf): </a:t>
+            </a:r>
+            <a:r>
+              <a:rPr b="0" sz="1050">
                 <a:solidFill>
                   <a:srgbClr val="475569"/>
                 </a:solidFill>
                 <a:latin typeface="Calibri"/>
               </a:rPr>
-              <a:t>Pemindaian otomatis direktori site-packages Linux via glob.glob saat startup.</a:t>
+              <a:t>Membundel pustaka pure-Python joblib &amp; fpdf2 di repositori untuk melewati pembatasan PEP 668 Debian Linux.</a:t>
             </a:r>
           </a:p>
           <a:p>
@@ -4115,22 +4115,22 @@
               </a:spcAft>
             </a:pPr>
             <a:r>
-              <a:rPr b="1" sz="1080">
+              <a:rPr b="1" sz="1050">
                 <a:solidFill>
                   <a:srgbClr val="0F172A"/>
                 </a:solidFill>
                 <a:latin typeface="Calibri"/>
               </a:rPr>
-              <a:t>• Dukungan Grafis Sistem (packages.txt): </a:t>
-            </a:r>
-            <a:r>
-              <a:rPr b="0" sz="1080">
+              <a:t>• Dynamic Path Discovery &amp; packages.txt: </a:t>
+            </a:r>
+            <a:r>
+              <a:rPr b="0" sz="1050">
                 <a:solidFill>
                   <a:srgbClr val="475569"/>
                 </a:solidFill>
                 <a:latin typeface="Calibri"/>
               </a:rPr>
-              <a:t>Menyertakan libxrender1 &amp; libxext6 agar RDKit dapat merender gambar 2D di server headless.</a:t>
+              <a:t>Pemindaian otomatis site-packages Linux serta dukungan libxrender1 &amp; libxext6 untuk RDKit.</a:t>
             </a:r>
           </a:p>
         </p:txBody>
@@ -7636,14 +7636,14 @@
           </a:p>
           <a:p>
             <a:pPr algn="ctr">
-              <a:defRPr sz="1250">
+              <a:defRPr sz="1200">
                 <a:solidFill>
                   <a:srgbClr val="BAE6FD"/>
                 </a:solidFill>
               </a:defRPr>
             </a:pPr>
             <a:r>
-              <a:t>Hanna Christina Ginting (NPM: 2506713353)  •  Pembimbing: Prof. Arry  •  Universitas Indonesia</a:t>
+              <a:t>🌐 Website Aplikasi: https://sglt2-drug-discovery.streamlit.app/  •  Hanna Christina Ginting (2506713353)  •  Prof. Arry (UI)</a:t>
             </a:r>
           </a:p>
         </p:txBody>

</xml_diff>